<commit_message>
fix(pitch): describe the pockets correctly — monthly account is the hub
Auto-Split card claimed the split goes into bills / vault / daily,
which is wrong per design_usecase.md: bills are reserved in the main
account, the vault takes its share, and the rest sits in the monthly
account, which the daily pocket is refilled from each midnight (and
backfilled from on overspend). Fix both cards and the section intro
(3 pockets: monthly / daily / vault) in the PDF source and the PPTX.
</commit_message>
<xml_diff>
--- a/docs/06-pitch/Three.py_1PagePitch.pptx
+++ b/docs/06-pitch/Three.py_1PagePitch.pptx
@@ -4348,7 +4348,7 @@
                 </a:solidFill>
                 <a:latin typeface="Tahoma"/>
               </a:rPr>
-              <a:t>Sapling ต่อยอดจากฟีเจอร์ ePocket ที่ K PLUS มีอยู่แล้ว ผ่านกลไก 3 ส่วนที่ทำงานร่วมกันโดยที่ผู้ใช้ไม่ต้องโยกเงินเอง</a:t>
+              <a:t>Sapling ต่อยอดจาก ePocket ที่ K PLUS มีอยู่แล้ว โดยจัดเงินเป็นกระเป๋า 3 ใบ คือ เงินรายเดือน ใช้จ่ายรายวัน และนิรภัย ผ่านกลไก 3 ส่วนที่ทำงานร่วมกันโดยผู้ใช้ไม่ต้องโยกเงินเอง</a:t>
             </a:r>
           </a:p>
         </p:txBody>
@@ -4480,7 +4480,7 @@
                 </a:solidFill>
                 <a:latin typeface="Tahoma"/>
               </a:rPr>
-              <a:t>เมื่อเงินเดือนเข้าบัญชี ระบบจะถามผู้ใช้ก่อนเสมอว่าต้องการแบ่งเงินตามแผนหรือไม่ แล้วจึงแบ่งเข้าบัญชีย่อยสามส่วน คือเงินกันไว้จ่ายบิล เงินออมในนิรภัย และเงินใช้จ่ายรายวัน หากตั้งให้จำผู้ส่ง รอบถัดไปจะทำงานอัตโนมัติทันที ใช้ได้ทั้งพนักงานประจำและฟรีแลนซ์ที่รายได้เข้าไม่ตรงงวด</a:t>
+              <a:t>เมื่อเงินเดือนเข้าบัญชี ระบบจะถามผู้ใช้ก่อนเสมอว่าต้องการแบ่งเงินตามแผนหรือไม่ แล้วกันเงินสำหรับบิลอัตโนมัติไว้ก่อน แบ่งส่วนออมเข้ากระเป๋านิรภัย และเก็บที่เหลือไว้ในบัญชีเงินรายเดือน หากตั้งให้จดจำผู้ส่ง รอบถัดไปจะทำงานอัตโนมัติทันที ใช้ได้ทั้งพนักงานประจำและฟรีแลนซ์ที่รายได้เข้าไม่ตรงงวด</a:t>
             </a:r>
           </a:p>
         </p:txBody>
@@ -4612,7 +4612,7 @@
                 </a:solidFill>
                 <a:latin typeface="Tahoma"/>
               </a:rPr>
-              <a:t>ทุกเที่ยงคืน ระบบจะเติมเงินในกระเป๋ารายวันให้ครบตามเป้าที่ตั้งไว้จากบัญชีเงินเดือน หากใช้เกินเป้าในวันนั้น ระบบจะไม่ปิดกั้นการใช้จ่าย แต่จะแจ้งเตือนพร้อมยอดคงเหลือให้เห็นทันที</a:t>
+              <a:t>ทุกเที่ยงคืน ระบบจะเติมกระเป๋าใช้จ่ายรายวันให้ครบตามเป้าที่ตั้งไว้ โดยดึงจากบัญชีเงินรายเดือน หากใช้เกินเป้าในวันนั้น ระบบจะไม่ปิดกั้นการใช้จ่าย แต่ดึงส่วนที่ขาดจากบัญชีเงินรายเดือนมาเติมให้ทันที พร้อมแจ้งเตือนยอดคงเหลือ</a:t>
             </a:r>
           </a:p>
         </p:txBody>

</xml_diff>

<commit_message>
docs(pitch): make the daily-allowance mechanic the headline of the solution
The core idea — split one monthly salary into money you can spend a
day at a time — was only a one-line refill card with no numbers, and
the tagline led with "auto-allocation" instead. Add a worked example
strip (22,500 -> vault 4,500 + monthly 18,000 -> 600/day -> midnight
refill, from the user flow in sapling_strategy.md), state how the
daily target is derived, and rewrite the tagline and section intro
around it. Trimmed other copy to stay on one page; PPTX mirrors it.
</commit_message>
<xml_diff>
--- a/docs/06-pitch/Three.py_1PagePitch.pptx
+++ b/docs/06-pitch/Three.py_1PagePitch.pptx
@@ -3148,8 +3148,8 @@
         </p:nvSpPr>
         <p:spPr>
           <a:xfrm>
-            <a:off x="540000" y="198000"/>
-            <a:ext cx="3600000" cy="396000"/>
+            <a:off x="540000" y="125999"/>
+            <a:ext cx="3600000" cy="432000"/>
           </a:xfrm>
           <a:prstGeom prst="rect">
             <a:avLst/>
@@ -3171,7 +3171,7 @@
               </a:spcAft>
             </a:pPr>
             <a:r>
-              <a:rPr sz="3200" b="1">
+              <a:rPr sz="3000" b="1">
                 <a:solidFill>
                   <a:srgbClr val="FFFFFF"/>
                 </a:solidFill>
@@ -3190,8 +3190,8 @@
         </p:nvSpPr>
         <p:spPr>
           <a:xfrm>
-            <a:off x="540000" y="594000"/>
-            <a:ext cx="3960000" cy="576000"/>
+            <a:off x="540000" y="702000"/>
+            <a:ext cx="3960000" cy="503999"/>
           </a:xfrm>
           <a:prstGeom prst="rect">
             <a:avLst/>
@@ -3219,7 +3219,7 @@
                 </a:solidFill>
                 <a:latin typeface="Tahoma"/>
               </a:rPr>
-              <a:t>ระบบจัดสรรเงินอัตโนมัติบน K PLUS สำหรับ First Jobbers กันบิลไว้ก่อน แบ่งเงินอัตโนมัติ ออมแบบมีวินัย</a:t>
+              <a:t>ระบบบน K PLUS สำหรับ First Jobbers แบ่งเงินเดือนให้ใช้ได้ทีละวัน กันบิลไว้ก่อน ออมแบบมีวินัย</a:t>
             </a:r>
           </a:p>
         </p:txBody>
@@ -4348,33 +4348,75 @@
                 </a:solidFill>
                 <a:latin typeface="Tahoma"/>
               </a:rPr>
-              <a:t>Sapling ต่อยอดจาก ePocket ที่ K PLUS มีอยู่แล้ว โดยจัดเงินเป็นกระเป๋า 3 ใบ คือ เงินรายเดือน ใช้จ่ายรายวัน และนิรภัย ผ่านกลไก 3 ส่วนที่ทำงานร่วมกันโดยผู้ใช้ไม่ต้องโยกเงินเอง</a:t>
-            </a:r>
-          </a:p>
-        </p:txBody>
-      </p:sp>
-      <p:sp>
-        <p:nvSpPr>
-          <p:cNvPr id="30" name="Rounded Rectangle 29"/>
+              <a:t>หัวใจของ Sapling คือแบ่งเงินเดือนก้อนเดียวให้ใช้ได้ทีละวัน บน ePocket เดิมของ K PLUS ผ่านกระเป๋า 3 ใบ: เงินรายเดือน ใช้จ่ายรายวัน นิรภัย</a:t>
+            </a:r>
+          </a:p>
+        </p:txBody>
+      </p:sp>
+      <p:sp>
+        <p:nvSpPr>
+          <p:cNvPr id="30" name="TextBox 29"/>
+          <p:cNvSpPr txBox="1"/>
+          <p:nvPr/>
+        </p:nvSpPr>
+        <p:spPr>
+          <a:xfrm>
+            <a:off x="540000" y="3416400"/>
+            <a:ext cx="6480000" cy="144000"/>
+          </a:xfrm>
+          <a:prstGeom prst="rect">
+            <a:avLst/>
+          </a:prstGeom>
+          <a:noFill/>
+        </p:spPr>
+        <p:txBody>
+          <a:bodyPr wrap="square" anchor="t" lIns="0" rIns="0" tIns="0" bIns="0">
+            <a:spAutoFit/>
+          </a:bodyPr>
+          <a:lstStyle/>
+          <a:p>
+            <a:pPr algn="l">
+              <a:lnSpc>
+                <a:spcPct val="115000"/>
+              </a:lnSpc>
+              <a:spcAft>
+                <a:spcPts val="0"/>
+              </a:spcAft>
+            </a:pPr>
+            <a:r>
+              <a:rPr sz="800" b="0">
+                <a:solidFill>
+                  <a:srgbClr val="5A6A5F"/>
+                </a:solidFill>
+                <a:latin typeface="Tahoma"/>
+              </a:rPr>
+              <a:t>ตัวอย่างพนักงานเงินเดือน 22,500 บาท (ยังไม่นับเงินที่กันไว้จ่ายบิล)</a:t>
+            </a:r>
+          </a:p>
+        </p:txBody>
+      </p:sp>
+      <p:sp>
+        <p:nvSpPr>
+          <p:cNvPr id="31" name="Rounded Rectangle 30"/>
           <p:cNvSpPr/>
           <p:nvPr/>
         </p:nvSpPr>
         <p:spPr>
           <a:xfrm>
-            <a:off x="540000" y="3416400"/>
-            <a:ext cx="2088000" cy="1404000"/>
+            <a:off x="540000" y="3578400"/>
+            <a:ext cx="1485000" cy="450000"/>
           </a:xfrm>
           <a:prstGeom prst="roundRect">
             <a:avLst>
-              <a:gd name="adj" fmla="val 6000"/>
+              <a:gd name="adj" fmla="val 10000"/>
             </a:avLst>
           </a:prstGeom>
           <a:solidFill>
-            <a:srgbClr val="FAFCFB"/>
+            <a:srgbClr val="F2F8F5"/>
           </a:solidFill>
           <a:ln w="9525">
             <a:solidFill>
-              <a:srgbClr val="DCE8E1"/>
+              <a:srgbClr val="B9D8C7"/>
             </a:solidFill>
           </a:ln>
           <a:effectLst/>
@@ -4403,14 +4445,14 @@
       </p:sp>
       <p:sp>
         <p:nvSpPr>
-          <p:cNvPr id="31" name="TextBox 30"/>
+          <p:cNvPr id="32" name="TextBox 31"/>
           <p:cNvSpPr txBox="1"/>
           <p:nvPr/>
         </p:nvSpPr>
         <p:spPr>
           <a:xfrm>
-            <a:off x="630000" y="3488400"/>
-            <a:ext cx="1908000" cy="216000"/>
+            <a:off x="612000" y="3614400"/>
+            <a:ext cx="1341000" cy="162000"/>
           </a:xfrm>
           <a:prstGeom prst="rect">
             <a:avLst/>
@@ -4432,27 +4474,27 @@
               </a:spcAft>
             </a:pPr>
             <a:r>
-              <a:rPr sz="1050" b="1">
-                <a:solidFill>
-                  <a:srgbClr val="1B2420"/>
+              <a:rPr sz="919" b="1">
+                <a:solidFill>
+                  <a:srgbClr val="0B5C43"/>
                 </a:solidFill>
                 <a:latin typeface="Tahoma"/>
               </a:rPr>
-              <a:t>Auto-Split ตอนเงินเข้า</a:t>
-            </a:r>
-          </a:p>
-        </p:txBody>
-      </p:sp>
-      <p:sp>
-        <p:nvSpPr>
-          <p:cNvPr id="32" name="TextBox 31"/>
+              <a:t>เงินเดือนเข้า 22,500 ฿</a:t>
+            </a:r>
+          </a:p>
+        </p:txBody>
+      </p:sp>
+      <p:sp>
+        <p:nvSpPr>
+          <p:cNvPr id="33" name="TextBox 32"/>
           <p:cNvSpPr txBox="1"/>
           <p:nvPr/>
         </p:nvSpPr>
         <p:spPr>
           <a:xfrm>
-            <a:off x="630000" y="3686400"/>
-            <a:ext cx="1908000" cy="1044000"/>
+            <a:off x="612000" y="3758400"/>
+            <a:ext cx="1341000" cy="251999"/>
           </a:xfrm>
           <a:prstGeom prst="rect">
             <a:avLst/>
@@ -4467,46 +4509,88 @@
           <a:p>
             <a:pPr algn="l">
               <a:lnSpc>
-                <a:spcPct val="120000"/>
+                <a:spcPct val="110000"/>
               </a:lnSpc>
               <a:spcAft>
                 <a:spcPts val="0"/>
               </a:spcAft>
             </a:pPr>
             <a:r>
-              <a:rPr sz="860" b="0">
+              <a:rPr sz="760" b="0">
                 <a:solidFill>
                   <a:srgbClr val="33403A"/>
                 </a:solidFill>
                 <a:latin typeface="Tahoma"/>
               </a:rPr>
-              <a:t>เมื่อเงินเดือนเข้าบัญชี ระบบจะถามผู้ใช้ก่อนเสมอว่าต้องการแบ่งเงินตามแผนหรือไม่ แล้วกันเงินสำหรับบิลอัตโนมัติไว้ก่อน แบ่งส่วนออมเข้ากระเป๋านิรภัย และเก็บที่เหลือไว้ในบัญชีเงินรายเดือน หากตั้งให้จดจำผู้ส่ง รอบถัดไปจะทำงานอัตโนมัติทันที ใช้ได้ทั้งพนักงานประจำและฟรีแลนซ์ที่รายได้เข้าไม่ตรงงวด</a:t>
-            </a:r>
-          </a:p>
-        </p:txBody>
-      </p:sp>
-      <p:sp>
-        <p:nvSpPr>
-          <p:cNvPr id="33" name="Rounded Rectangle 32"/>
+              <a:t>ระบบถามยืนยันก่อนแบ่ง</a:t>
+            </a:r>
+          </a:p>
+        </p:txBody>
+      </p:sp>
+      <p:sp>
+        <p:nvSpPr>
+          <p:cNvPr id="34" name="TextBox 33"/>
+          <p:cNvSpPr txBox="1"/>
+          <p:nvPr/>
+        </p:nvSpPr>
+        <p:spPr>
+          <a:xfrm>
+            <a:off x="2025000" y="3704399"/>
+            <a:ext cx="180000" cy="180000"/>
+          </a:xfrm>
+          <a:prstGeom prst="rect">
+            <a:avLst/>
+          </a:prstGeom>
+          <a:noFill/>
+        </p:spPr>
+        <p:txBody>
+          <a:bodyPr wrap="square" anchor="t" lIns="0" rIns="0" tIns="0" bIns="0">
+            <a:spAutoFit/>
+          </a:bodyPr>
+          <a:lstStyle/>
+          <a:p>
+            <a:pPr algn="ctr">
+              <a:lnSpc>
+                <a:spcPct val="115000"/>
+              </a:lnSpc>
+              <a:spcAft>
+                <a:spcPts val="0"/>
+              </a:spcAft>
+            </a:pPr>
+            <a:r>
+              <a:rPr sz="1100" b="1">
+                <a:solidFill>
+                  <a:srgbClr val="0E7C5A"/>
+                </a:solidFill>
+                <a:latin typeface="Tahoma"/>
+              </a:rPr>
+              <a:t>→</a:t>
+            </a:r>
+          </a:p>
+        </p:txBody>
+      </p:sp>
+      <p:sp>
+        <p:nvSpPr>
+          <p:cNvPr id="35" name="Rounded Rectangle 34"/>
           <p:cNvSpPr/>
           <p:nvPr/>
         </p:nvSpPr>
         <p:spPr>
           <a:xfrm>
-            <a:off x="2736000" y="3416400"/>
-            <a:ext cx="2088000" cy="1404000"/>
+            <a:off x="2205000" y="3578400"/>
+            <a:ext cx="1485000" cy="450000"/>
           </a:xfrm>
           <a:prstGeom prst="roundRect">
             <a:avLst>
-              <a:gd name="adj" fmla="val 6000"/>
+              <a:gd name="adj" fmla="val 10000"/>
             </a:avLst>
           </a:prstGeom>
           <a:solidFill>
-            <a:srgbClr val="FAFCFB"/>
+            <a:srgbClr val="F2F8F5"/>
           </a:solidFill>
           <a:ln w="9525">
             <a:solidFill>
-              <a:srgbClr val="DCE8E1"/>
+              <a:srgbClr val="B9D8C7"/>
             </a:solidFill>
           </a:ln>
           <a:effectLst/>
@@ -4535,14 +4619,14 @@
       </p:sp>
       <p:sp>
         <p:nvSpPr>
-          <p:cNvPr id="34" name="TextBox 33"/>
+          <p:cNvPr id="36" name="TextBox 35"/>
           <p:cNvSpPr txBox="1"/>
           <p:nvPr/>
         </p:nvSpPr>
         <p:spPr>
           <a:xfrm>
-            <a:off x="2826000" y="3488400"/>
-            <a:ext cx="1908000" cy="216000"/>
+            <a:off x="2277000" y="3614400"/>
+            <a:ext cx="1341000" cy="162000"/>
           </a:xfrm>
           <a:prstGeom prst="rect">
             <a:avLst/>
@@ -4564,27 +4648,27 @@
               </a:spcAft>
             </a:pPr>
             <a:r>
-              <a:rPr sz="1050" b="1">
-                <a:solidFill>
-                  <a:srgbClr val="1B2420"/>
+              <a:rPr sz="919" b="1">
+                <a:solidFill>
+                  <a:srgbClr val="0B5C43"/>
                 </a:solidFill>
                 <a:latin typeface="Tahoma"/>
               </a:rPr>
-              <a:t>Daily Auto-Refill</a:t>
-            </a:r>
-          </a:p>
-        </p:txBody>
-      </p:sp>
-      <p:sp>
-        <p:nvSpPr>
-          <p:cNvPr id="35" name="TextBox 34"/>
+              <a:t>นิรภัย 4,500 ฿</a:t>
+            </a:r>
+          </a:p>
+        </p:txBody>
+      </p:sp>
+      <p:sp>
+        <p:nvSpPr>
+          <p:cNvPr id="37" name="TextBox 36"/>
           <p:cNvSpPr txBox="1"/>
           <p:nvPr/>
         </p:nvSpPr>
         <p:spPr>
           <a:xfrm>
-            <a:off x="2826000" y="3686400"/>
-            <a:ext cx="1908000" cy="1044000"/>
+            <a:off x="2277000" y="3758400"/>
+            <a:ext cx="1341000" cy="251999"/>
           </a:xfrm>
           <a:prstGeom prst="rect">
             <a:avLst/>
@@ -4599,46 +4683,88 @@
           <a:p>
             <a:pPr algn="l">
               <a:lnSpc>
-                <a:spcPct val="120000"/>
+                <a:spcPct val="110000"/>
               </a:lnSpc>
               <a:spcAft>
                 <a:spcPts val="0"/>
               </a:spcAft>
             </a:pPr>
             <a:r>
-              <a:rPr sz="860" b="0">
+              <a:rPr sz="760" b="0">
                 <a:solidFill>
                   <a:srgbClr val="33403A"/>
                 </a:solidFill>
                 <a:latin typeface="Tahoma"/>
               </a:rPr>
-              <a:t>ทุกเที่ยงคืน ระบบจะเติมกระเป๋าใช้จ่ายรายวันให้ครบตามเป้าที่ตั้งไว้ โดยดึงจากบัญชีเงินรายเดือน หากใช้เกินเป้าในวันนั้น ระบบจะไม่ปิดกั้นการใช้จ่าย แต่ดึงส่วนที่ขาดจากบัญชีเงินรายเดือนมาเติมให้ทันที พร้อมแจ้งเตือนยอดคงเหลือ</a:t>
-            </a:r>
-          </a:p>
-        </p:txBody>
-      </p:sp>
-      <p:sp>
-        <p:nvSpPr>
-          <p:cNvPr id="36" name="Rounded Rectangle 35"/>
+              <a:t>บัญชีเงินรายเดือน 18,000 ฿</a:t>
+            </a:r>
+          </a:p>
+        </p:txBody>
+      </p:sp>
+      <p:sp>
+        <p:nvSpPr>
+          <p:cNvPr id="38" name="TextBox 37"/>
+          <p:cNvSpPr txBox="1"/>
+          <p:nvPr/>
+        </p:nvSpPr>
+        <p:spPr>
+          <a:xfrm>
+            <a:off x="3690000" y="3704399"/>
+            <a:ext cx="180000" cy="180000"/>
+          </a:xfrm>
+          <a:prstGeom prst="rect">
+            <a:avLst/>
+          </a:prstGeom>
+          <a:noFill/>
+        </p:spPr>
+        <p:txBody>
+          <a:bodyPr wrap="square" anchor="t" lIns="0" rIns="0" tIns="0" bIns="0">
+            <a:spAutoFit/>
+          </a:bodyPr>
+          <a:lstStyle/>
+          <a:p>
+            <a:pPr algn="ctr">
+              <a:lnSpc>
+                <a:spcPct val="115000"/>
+              </a:lnSpc>
+              <a:spcAft>
+                <a:spcPts val="0"/>
+              </a:spcAft>
+            </a:pPr>
+            <a:r>
+              <a:rPr sz="1100" b="1">
+                <a:solidFill>
+                  <a:srgbClr val="0E7C5A"/>
+                </a:solidFill>
+                <a:latin typeface="Tahoma"/>
+              </a:rPr>
+              <a:t>→</a:t>
+            </a:r>
+          </a:p>
+        </p:txBody>
+      </p:sp>
+      <p:sp>
+        <p:nvSpPr>
+          <p:cNvPr id="39" name="Rounded Rectangle 38"/>
           <p:cNvSpPr/>
           <p:nvPr/>
         </p:nvSpPr>
         <p:spPr>
           <a:xfrm>
-            <a:off x="4932000" y="3416400"/>
-            <a:ext cx="2088000" cy="1404000"/>
+            <a:off x="3870000" y="3578400"/>
+            <a:ext cx="1485000" cy="450000"/>
           </a:xfrm>
           <a:prstGeom prst="roundRect">
             <a:avLst>
-              <a:gd name="adj" fmla="val 6000"/>
+              <a:gd name="adj" fmla="val 10000"/>
             </a:avLst>
           </a:prstGeom>
           <a:solidFill>
-            <a:srgbClr val="FAFCFB"/>
+            <a:srgbClr val="F2F8F5"/>
           </a:solidFill>
           <a:ln w="9525">
             <a:solidFill>
-              <a:srgbClr val="DCE8E1"/>
+              <a:srgbClr val="B9D8C7"/>
             </a:solidFill>
           </a:ln>
           <a:effectLst/>
@@ -4667,14 +4793,14 @@
       </p:sp>
       <p:sp>
         <p:nvSpPr>
-          <p:cNvPr id="37" name="TextBox 36"/>
+          <p:cNvPr id="40" name="TextBox 39"/>
           <p:cNvSpPr txBox="1"/>
           <p:nvPr/>
         </p:nvSpPr>
         <p:spPr>
           <a:xfrm>
-            <a:off x="5022000" y="3488400"/>
-            <a:ext cx="1908000" cy="216000"/>
+            <a:off x="3942000" y="3614400"/>
+            <a:ext cx="1341000" cy="162000"/>
           </a:xfrm>
           <a:prstGeom prst="rect">
             <a:avLst/>
@@ -4696,27 +4822,27 @@
               </a:spcAft>
             </a:pPr>
             <a:r>
-              <a:rPr sz="1050" b="1">
-                <a:solidFill>
-                  <a:srgbClr val="1B2420"/>
+              <a:rPr sz="919" b="1">
+                <a:solidFill>
+                  <a:srgbClr val="0B5C43"/>
                 </a:solidFill>
                 <a:latin typeface="Tahoma"/>
               </a:rPr>
-              <a:t>กระเป๋านิรภัย (Vault)</a:t>
-            </a:r>
-          </a:p>
-        </p:txBody>
-      </p:sp>
-      <p:sp>
-        <p:nvSpPr>
-          <p:cNvPr id="38" name="TextBox 37"/>
+              <a:t>เป้ารายวัน 600 ฿</a:t>
+            </a:r>
+          </a:p>
+        </p:txBody>
+      </p:sp>
+      <p:sp>
+        <p:nvSpPr>
+          <p:cNvPr id="41" name="TextBox 40"/>
           <p:cNvSpPr txBox="1"/>
           <p:nvPr/>
         </p:nvSpPr>
         <p:spPr>
           <a:xfrm>
-            <a:off x="5022000" y="3686400"/>
-            <a:ext cx="1908000" cy="1044000"/>
+            <a:off x="3942000" y="3758400"/>
+            <a:ext cx="1341000" cy="251999"/>
           </a:xfrm>
           <a:prstGeom prst="rect">
             <a:avLst/>
@@ -4731,38 +4857,80 @@
           <a:p>
             <a:pPr algn="l">
               <a:lnSpc>
-                <a:spcPct val="120000"/>
+                <a:spcPct val="110000"/>
               </a:lnSpc>
               <a:spcAft>
                 <a:spcPts val="0"/>
               </a:spcAft>
             </a:pPr>
             <a:r>
-              <a:rPr sz="860" b="0">
+              <a:rPr sz="760" b="0">
                 <a:solidFill>
                   <a:srgbClr val="33403A"/>
                 </a:solidFill>
                 <a:latin typeface="Tahoma"/>
               </a:rPr>
-              <a:t>เงินในกระเป๋านี้จะถอนออกไม่ได้ทันที ต้องรอผ่านช่วงเวลาที่กำหนดไว้ก่อน แล้วระบบจะปล่อยเงินให้อัตโนมัติ แนวคิดนี้อ้างอิงจากงานวิจัยด้าน commitment device (Ashraf, Karlan &amp; Yin, QJE 2006) ที่ยืนยันว่าผู้ใช้ยอมรับกลไกลักษณะนี้ได้จริงแม้ไม่มีผลตอบแทนพิเศษ</a:t>
-            </a:r>
-          </a:p>
-        </p:txBody>
-      </p:sp>
-      <p:sp>
-        <p:nvSpPr>
-          <p:cNvPr id="39" name="Rounded Rectangle 38"/>
+              <a:t>18,000 ÷ 30 วัน ผู้ใช้กดรับหรือแก้เองได้</a:t>
+            </a:r>
+          </a:p>
+        </p:txBody>
+      </p:sp>
+      <p:sp>
+        <p:nvSpPr>
+          <p:cNvPr id="42" name="TextBox 41"/>
+          <p:cNvSpPr txBox="1"/>
+          <p:nvPr/>
+        </p:nvSpPr>
+        <p:spPr>
+          <a:xfrm>
+            <a:off x="5355000" y="3704399"/>
+            <a:ext cx="180000" cy="180000"/>
+          </a:xfrm>
+          <a:prstGeom prst="rect">
+            <a:avLst/>
+          </a:prstGeom>
+          <a:noFill/>
+        </p:spPr>
+        <p:txBody>
+          <a:bodyPr wrap="square" anchor="t" lIns="0" rIns="0" tIns="0" bIns="0">
+            <a:spAutoFit/>
+          </a:bodyPr>
+          <a:lstStyle/>
+          <a:p>
+            <a:pPr algn="ctr">
+              <a:lnSpc>
+                <a:spcPct val="115000"/>
+              </a:lnSpc>
+              <a:spcAft>
+                <a:spcPts val="0"/>
+              </a:spcAft>
+            </a:pPr>
+            <a:r>
+              <a:rPr sz="1100" b="1">
+                <a:solidFill>
+                  <a:srgbClr val="0E7C5A"/>
+                </a:solidFill>
+                <a:latin typeface="Tahoma"/>
+              </a:rPr>
+              <a:t>→</a:t>
+            </a:r>
+          </a:p>
+        </p:txBody>
+      </p:sp>
+      <p:sp>
+        <p:nvSpPr>
+          <p:cNvPr id="43" name="Rounded Rectangle 42"/>
           <p:cNvSpPr/>
           <p:nvPr/>
         </p:nvSpPr>
         <p:spPr>
           <a:xfrm>
-            <a:off x="540000" y="4910400"/>
-            <a:ext cx="6480000" cy="468000"/>
+            <a:off x="5535000" y="3578400"/>
+            <a:ext cx="1485000" cy="450000"/>
           </a:xfrm>
           <a:prstGeom prst="roundRect">
             <a:avLst>
-              <a:gd name="adj" fmla="val 12000"/>
+              <a:gd name="adj" fmla="val 10000"/>
             </a:avLst>
           </a:prstGeom>
           <a:solidFill>
@@ -4772,7 +4940,6 @@
             <a:solidFill>
               <a:srgbClr val="B9D8C7"/>
             </a:solidFill>
-            <a:prstDash val="dash"/>
           </a:ln>
           <a:effectLst/>
         </p:spPr>
@@ -4800,65 +4967,14 @@
       </p:sp>
       <p:sp>
         <p:nvSpPr>
-          <p:cNvPr id="40" name="TextBox 39"/>
+          <p:cNvPr id="44" name="TextBox 43"/>
           <p:cNvSpPr txBox="1"/>
           <p:nvPr/>
         </p:nvSpPr>
         <p:spPr>
           <a:xfrm>
-            <a:off x="648000" y="4964400"/>
-            <a:ext cx="6264000" cy="360000"/>
-          </a:xfrm>
-          <a:prstGeom prst="rect">
-            <a:avLst/>
-          </a:prstGeom>
-          <a:noFill/>
-        </p:spPr>
-        <p:txBody>
-          <a:bodyPr wrap="square" anchor="t" lIns="0" rIns="0" tIns="0" bIns="0">
-            <a:spAutoFit/>
-          </a:bodyPr>
-          <a:lstStyle/>
-          <a:p>
-            <a:pPr algn="l">
-              <a:lnSpc>
-                <a:spcPct val="120000"/>
-              </a:lnSpc>
-              <a:spcAft>
-                <a:spcPts val="0"/>
-              </a:spcAft>
-            </a:pPr>
-            <a:r>
-              <a:rPr sz="860" b="1">
-                <a:solidFill>
-                  <a:srgbClr val="0B5C43"/>
-                </a:solidFill>
-                <a:latin typeface="Tahoma"/>
-              </a:rPr>
-              <a:t>จุดเล็กๆ ที่ใส่ใจ: </a:t>
-            </a:r>
-            <a:r>
-              <a:rPr sz="860" b="0">
-                <a:solidFill>
-                  <a:srgbClr val="33403A"/>
-                </a:solidFill>
-                <a:latin typeface="Tahoma"/>
-              </a:rPr>
-              <a:t>หน้าจอกระเป๋านิรภัยมีต้นไม้ที่โตขึ้นเป็นระยะตามจำนวนรอบที่ออมต่อเนื่อง ไม่ใช่ยอดเงิน คนเงินเดือนน้อยจึงโตได้เท่าคนเงินเดือนมาก และถอนเงินก็ไม่ทำให้ต้นไม้ตาย เป็นแรงจูงใจง่ายๆ ให้อยากกลับมาออมสม่ำเสมอ</a:t>
-            </a:r>
-          </a:p>
-        </p:txBody>
-      </p:sp>
-      <p:sp>
-        <p:nvSpPr>
-          <p:cNvPr id="41" name="TextBox 40"/>
-          <p:cNvSpPr txBox="1"/>
-          <p:nvPr/>
-        </p:nvSpPr>
-        <p:spPr>
-          <a:xfrm>
-            <a:off x="540000" y="5522400"/>
-            <a:ext cx="3150000" cy="251999"/>
+            <a:off x="5607000" y="3614400"/>
+            <a:ext cx="1341000" cy="162000"/>
           </a:xfrm>
           <a:prstGeom prst="rect">
             <a:avLst/>
@@ -4880,27 +4996,27 @@
               </a:spcAft>
             </a:pPr>
             <a:r>
-              <a:rPr sz="1500" b="1">
+              <a:rPr sz="919" b="1">
                 <a:solidFill>
                   <a:srgbClr val="0B5C43"/>
                 </a:solidFill>
                 <a:latin typeface="Tahoma"/>
               </a:rPr>
-              <a:t>Target Users</a:t>
-            </a:r>
-          </a:p>
-        </p:txBody>
-      </p:sp>
-      <p:sp>
-        <p:nvSpPr>
-          <p:cNvPr id="42" name="TextBox 41"/>
+              <a:t>เติมทุกเที่ยงคืน</a:t>
+            </a:r>
+          </a:p>
+        </p:txBody>
+      </p:sp>
+      <p:sp>
+        <p:nvSpPr>
+          <p:cNvPr id="45" name="TextBox 44"/>
           <p:cNvSpPr txBox="1"/>
           <p:nvPr/>
         </p:nvSpPr>
         <p:spPr>
           <a:xfrm>
-            <a:off x="540000" y="5745600"/>
-            <a:ext cx="3150000" cy="1440000"/>
+            <a:off x="5607000" y="3758400"/>
+            <a:ext cx="1341000" cy="251999"/>
           </a:xfrm>
           <a:prstGeom prst="rect">
             <a:avLst/>
@@ -4915,255 +5031,47 @@
           <a:p>
             <a:pPr algn="l">
               <a:lnSpc>
-                <a:spcPct val="128000"/>
+                <a:spcPct val="110000"/>
               </a:lnSpc>
               <a:spcAft>
                 <a:spcPts val="0"/>
               </a:spcAft>
             </a:pPr>
             <a:r>
-              <a:rPr sz="930" b="0">
-                <a:solidFill>
-                  <a:srgbClr val="1B2420"/>
+              <a:rPr sz="760" b="0">
+                <a:solidFill>
+                  <a:srgbClr val="33403A"/>
                 </a:solidFill>
                 <a:latin typeface="Tahoma"/>
               </a:rPr>
-              <a:t>ผู้ใช้ K PLUS อายุ 22–30 ปี กลุ่ม First Jobbers ที่รายได้ปานกลางถึงจำกัด เช่น พนักงานออฟฟิศเงินเดือน 22,500 บาทที่เข้าตรงเวลาทุกเดือน หรือฟรีแลนซ์ที่ลูกค้าโอนเงินไม่ตรงงวด คนกลุ่มนี้มีรายรับแต่จัดสรรเงินเองไม่ทัน โดยเฉพาะกลุ่มที่เช่าบ้านหรือคอนโดในเมืองซึ่งค่าครองชีพสูงเมื่อเทียบกับรายได้</a:t>
-            </a:r>
-          </a:p>
-        </p:txBody>
-      </p:sp>
-      <p:sp>
-        <p:nvSpPr>
-          <p:cNvPr id="43" name="TextBox 42"/>
-          <p:cNvSpPr txBox="1"/>
-          <p:nvPr/>
-        </p:nvSpPr>
-        <p:spPr>
-          <a:xfrm>
-            <a:off x="3870000" y="5522400"/>
-            <a:ext cx="3150000" cy="251999"/>
-          </a:xfrm>
-          <a:prstGeom prst="rect">
-            <a:avLst/>
-          </a:prstGeom>
-          <a:noFill/>
-        </p:spPr>
-        <p:txBody>
-          <a:bodyPr wrap="square" anchor="t" lIns="0" rIns="0" tIns="0" bIns="0">
-            <a:spAutoFit/>
-          </a:bodyPr>
-          <a:lstStyle/>
-          <a:p>
-            <a:pPr algn="l">
-              <a:lnSpc>
-                <a:spcPct val="115000"/>
-              </a:lnSpc>
-              <a:spcAft>
-                <a:spcPts val="0"/>
-              </a:spcAft>
-            </a:pPr>
-            <a:r>
-              <a:rPr sz="1500" b="1">
-                <a:solidFill>
-                  <a:srgbClr val="0B5C43"/>
-                </a:solidFill>
-                <a:latin typeface="Tahoma"/>
-              </a:rPr>
-              <a:t>Track Perspective — Track 1</a:t>
-            </a:r>
-          </a:p>
-        </p:txBody>
-      </p:sp>
-      <p:sp>
-        <p:nvSpPr>
-          <p:cNvPr id="44" name="TextBox 43"/>
-          <p:cNvSpPr txBox="1"/>
-          <p:nvPr/>
-        </p:nvSpPr>
-        <p:spPr>
-          <a:xfrm>
-            <a:off x="3870000" y="5745600"/>
-            <a:ext cx="3150000" cy="540000"/>
-          </a:xfrm>
-          <a:prstGeom prst="rect">
-            <a:avLst/>
-          </a:prstGeom>
-          <a:noFill/>
-        </p:spPr>
-        <p:txBody>
-          <a:bodyPr wrap="square" anchor="t" lIns="0" rIns="0" tIns="0" bIns="0">
-            <a:spAutoFit/>
-          </a:bodyPr>
-          <a:lstStyle/>
-          <a:p>
-            <a:pPr algn="l">
-              <a:lnSpc>
-                <a:spcPct val="122000"/>
-              </a:lnSpc>
-              <a:spcAft>
-                <a:spcPts val="0"/>
-              </a:spcAft>
-            </a:pPr>
-            <a:r>
-              <a:rPr sz="930" b="0">
-                <a:solidFill>
-                  <a:srgbClr val="1B2420"/>
-                </a:solidFill>
-                <a:latin typeface="Tahoma"/>
-              </a:rPr>
-              <a:t>ด้านการพัฒนา ออกแบบ rule engine แยกเป็นโมดูลที่ทดสอบง่าย ให้สถานะรอถอนเงินอ้างอิงจากเซิร์ฟเวอร์เท่านั้น และบันทึกทุกรายการผ่าน ledger ที่เขียนทางเดียวเพื่อกันข้อมูลผิดเพี้ยน</a:t>
-            </a:r>
-          </a:p>
-        </p:txBody>
-      </p:sp>
-      <p:sp>
-        <p:nvSpPr>
-          <p:cNvPr id="45" name="TextBox 44"/>
-          <p:cNvSpPr txBox="1"/>
-          <p:nvPr/>
-        </p:nvSpPr>
-        <p:spPr>
-          <a:xfrm>
-            <a:off x="3870000" y="6256800"/>
-            <a:ext cx="3150000" cy="540000"/>
-          </a:xfrm>
-          <a:prstGeom prst="rect">
-            <a:avLst/>
-          </a:prstGeom>
-          <a:noFill/>
-        </p:spPr>
-        <p:txBody>
-          <a:bodyPr wrap="square" anchor="t" lIns="0" rIns="0" tIns="0" bIns="0">
-            <a:spAutoFit/>
-          </a:bodyPr>
-          <a:lstStyle/>
-          <a:p>
-            <a:pPr algn="l">
-              <a:lnSpc>
-                <a:spcPct val="122000"/>
-              </a:lnSpc>
-              <a:spcAft>
-                <a:spcPts val="0"/>
-              </a:spcAft>
-            </a:pPr>
-            <a:r>
-              <a:rPr sz="930" b="0">
-                <a:solidFill>
-                  <a:srgbClr val="1B2420"/>
-                </a:solidFill>
-                <a:latin typeface="Tahoma"/>
-              </a:rPr>
-              <a:t>ด้านการทดสอบ ใช้ property test สุ่มธุรกรรมกว่าหมื่นรายการยืนยันว่ายอดเงินทุกบัญชีถูกต้องเสมอ ร่วมกับ unit และ integration test ครอบคลุมกรณีย่อยกว่า 50 จุด และทดสอบ idempotency กับ concurrency โดยเฉพาะ</a:t>
-            </a:r>
-          </a:p>
-        </p:txBody>
-      </p:sp>
-      <p:sp>
-        <p:nvSpPr>
-          <p:cNvPr id="46" name="TextBox 45"/>
-          <p:cNvSpPr txBox="1"/>
-          <p:nvPr/>
-        </p:nvSpPr>
-        <p:spPr>
-          <a:xfrm>
-            <a:off x="3870000" y="6768000"/>
-            <a:ext cx="3150000" cy="540000"/>
-          </a:xfrm>
-          <a:prstGeom prst="rect">
-            <a:avLst/>
-          </a:prstGeom>
-          <a:noFill/>
-        </p:spPr>
-        <p:txBody>
-          <a:bodyPr wrap="square" anchor="t" lIns="0" rIns="0" tIns="0" bIns="0">
-            <a:spAutoFit/>
-          </a:bodyPr>
-          <a:lstStyle/>
-          <a:p>
-            <a:pPr algn="l">
-              <a:lnSpc>
-                <a:spcPct val="122000"/>
-              </a:lnSpc>
-              <a:spcAft>
-                <a:spcPts val="0"/>
-              </a:spcAft>
-            </a:pPr>
-            <a:r>
-              <a:rPr sz="930" b="0">
-                <a:solidFill>
-                  <a:srgbClr val="1B2420"/>
-                </a:solidFill>
-                <a:latin typeface="Tahoma"/>
-              </a:rPr>
-              <a:t>ด้านการรับประกันคุณภาพ วางแผนทดสอบการใช้งานจริงกับผู้ใช้ 5–8 คนตาม protocol ที่กำหนดไว้ล่วงหน้า พร้อม checklist ตามหลัก PDPA</a:t>
-            </a:r>
-          </a:p>
-        </p:txBody>
-      </p:sp>
-      <p:sp>
-        <p:nvSpPr>
-          <p:cNvPr id="47" name="TextBox 46"/>
-          <p:cNvSpPr txBox="1"/>
-          <p:nvPr/>
-        </p:nvSpPr>
-        <p:spPr>
-          <a:xfrm>
-            <a:off x="540000" y="7646400"/>
-            <a:ext cx="6480000" cy="251999"/>
-          </a:xfrm>
-          <a:prstGeom prst="rect">
-            <a:avLst/>
-          </a:prstGeom>
-          <a:noFill/>
-        </p:spPr>
-        <p:txBody>
-          <a:bodyPr wrap="square" anchor="t" lIns="0" rIns="0" tIns="0" bIns="0">
-            <a:spAutoFit/>
-          </a:bodyPr>
-          <a:lstStyle/>
-          <a:p>
-            <a:pPr algn="l">
-              <a:lnSpc>
-                <a:spcPct val="115000"/>
-              </a:lnSpc>
-              <a:spcAft>
-                <a:spcPts val="0"/>
-              </a:spcAft>
-            </a:pPr>
-            <a:r>
-              <a:rPr sz="1500" b="1">
-                <a:solidFill>
-                  <a:srgbClr val="0B5C43"/>
-                </a:solidFill>
-                <a:latin typeface="Tahoma"/>
-              </a:rPr>
-              <a:t>Value Proposition</a:t>
-            </a:r>
-          </a:p>
-        </p:txBody>
-      </p:sp>
-      <p:sp>
-        <p:nvSpPr>
-          <p:cNvPr id="48" name="Rounded Rectangle 47"/>
+              <a:t>กระเป๋ารายวันถูกเติมให้ถึง 600 ฿ จากบัญชีรายเดือน</a:t>
+            </a:r>
+          </a:p>
+        </p:txBody>
+      </p:sp>
+      <p:sp>
+        <p:nvSpPr>
+          <p:cNvPr id="46" name="Rounded Rectangle 45"/>
           <p:cNvSpPr/>
           <p:nvPr/>
         </p:nvSpPr>
         <p:spPr>
           <a:xfrm>
-            <a:off x="540000" y="7869600"/>
-            <a:ext cx="3150000" cy="972000"/>
+            <a:off x="540000" y="4136400"/>
+            <a:ext cx="2088000" cy="1404000"/>
           </a:xfrm>
           <a:prstGeom prst="roundRect">
             <a:avLst>
-              <a:gd name="adj" fmla="val 8000"/>
+              <a:gd name="adj" fmla="val 6000"/>
             </a:avLst>
           </a:prstGeom>
           <a:solidFill>
-            <a:srgbClr val="F2F8F5"/>
+            <a:srgbClr val="FAFCFB"/>
           </a:solidFill>
-          <a:ln>
-            <a:noFill/>
+          <a:ln w="9525">
+            <a:solidFill>
+              <a:srgbClr val="DCE8E1"/>
+            </a:solidFill>
           </a:ln>
           <a:effectLst/>
         </p:spPr>
@@ -5191,14 +5099,14 @@
       </p:sp>
       <p:sp>
         <p:nvSpPr>
-          <p:cNvPr id="49" name="TextBox 48"/>
+          <p:cNvPr id="47" name="TextBox 46"/>
           <p:cNvSpPr txBox="1"/>
           <p:nvPr/>
         </p:nvSpPr>
         <p:spPr>
           <a:xfrm>
-            <a:off x="648000" y="7941600"/>
-            <a:ext cx="2934000" cy="180000"/>
+            <a:off x="630000" y="4208400"/>
+            <a:ext cx="1908000" cy="216000"/>
           </a:xfrm>
           <a:prstGeom prst="rect">
             <a:avLst/>
@@ -5222,25 +5130,25 @@
             <a:r>
               <a:rPr sz="1050" b="1">
                 <a:solidFill>
-                  <a:srgbClr val="0B5C43"/>
+                  <a:srgbClr val="1B2420"/>
                 </a:solidFill>
                 <a:latin typeface="Tahoma"/>
               </a:rPr>
-              <a:t>ผู้ใช้</a:t>
-            </a:r>
-          </a:p>
-        </p:txBody>
-      </p:sp>
-      <p:sp>
-        <p:nvSpPr>
-          <p:cNvPr id="50" name="TextBox 49"/>
+              <a:t>Auto-Split ตอนเงินเข้า</a:t>
+            </a:r>
+          </a:p>
+        </p:txBody>
+      </p:sp>
+      <p:sp>
+        <p:nvSpPr>
+          <p:cNvPr id="48" name="TextBox 47"/>
           <p:cNvSpPr txBox="1"/>
           <p:nvPr/>
         </p:nvSpPr>
         <p:spPr>
           <a:xfrm>
-            <a:off x="648000" y="8139600"/>
-            <a:ext cx="2934000" cy="630000"/>
+            <a:off x="630000" y="4406400"/>
+            <a:ext cx="1908000" cy="1044000"/>
           </a:xfrm>
           <a:prstGeom prst="rect">
             <a:avLst/>
@@ -5255,45 +5163,47 @@
           <a:p>
             <a:pPr algn="l">
               <a:lnSpc>
-                <a:spcPct val="122000"/>
+                <a:spcPct val="120000"/>
               </a:lnSpc>
               <a:spcAft>
                 <a:spcPts val="0"/>
               </a:spcAft>
             </a:pPr>
             <a:r>
-              <a:rPr sz="880" b="0">
+              <a:rPr sz="860" b="0">
                 <a:solidFill>
                   <a:srgbClr val="33403A"/>
                 </a:solidFill>
                 <a:latin typeface="Tahoma"/>
               </a:rPr>
-              <a:t>ผู้ใช้ไม่ต้องแบ่งเงินเอง เห็นเงินออมของตัวเองเติบโตขึ้นอย่างเป็นระบบ และมีเวลาคิดทบทวนมากขึ้นก่อนจะใช้เงินก้อนที่ออมไว้ ซึ่งในกรณีที่กำลังจะโอนเงินออมให้มิจฉาชีพโดยไม่ทันคิด ช่วงเวลารอนี้อาจช่วยลดความเสียหายได้บ้าง</a:t>
-            </a:r>
-          </a:p>
-        </p:txBody>
-      </p:sp>
-      <p:sp>
-        <p:nvSpPr>
-          <p:cNvPr id="51" name="Rounded Rectangle 50"/>
+              <a:t>เมื่อเงินเดือนเข้า ระบบถามยืนยันก่อนเสมอ แล้วกันเงินสำหรับบิลไว้ก่อน แบ่งส่วนออมเข้ากระเป๋านิรภัย และเก็บที่เหลือไว้ในบัญชีเงินรายเดือน หากตั้งให้จดจำผู้ส่ง รอบถัดไปทำงานอัตโนมัติทันที ใช้ได้ทั้งพนักงานประจำและฟรีแลนซ์ที่รายได้เข้าไม่ตรงงวด</a:t>
+            </a:r>
+          </a:p>
+        </p:txBody>
+      </p:sp>
+      <p:sp>
+        <p:nvSpPr>
+          <p:cNvPr id="49" name="Rounded Rectangle 48"/>
           <p:cNvSpPr/>
           <p:nvPr/>
         </p:nvSpPr>
         <p:spPr>
           <a:xfrm>
-            <a:off x="3870000" y="7869600"/>
-            <a:ext cx="3150000" cy="972000"/>
+            <a:off x="2736000" y="4136400"/>
+            <a:ext cx="2088000" cy="1404000"/>
           </a:xfrm>
           <a:prstGeom prst="roundRect">
             <a:avLst>
-              <a:gd name="adj" fmla="val 8000"/>
+              <a:gd name="adj" fmla="val 6000"/>
             </a:avLst>
           </a:prstGeom>
           <a:solidFill>
-            <a:srgbClr val="F2F8F5"/>
+            <a:srgbClr val="FAFCFB"/>
           </a:solidFill>
-          <a:ln>
-            <a:noFill/>
+          <a:ln w="9525">
+            <a:solidFill>
+              <a:srgbClr val="DCE8E1"/>
+            </a:solidFill>
           </a:ln>
           <a:effectLst/>
         </p:spPr>
@@ -5321,14 +5231,14 @@
       </p:sp>
       <p:sp>
         <p:nvSpPr>
-          <p:cNvPr id="52" name="TextBox 51"/>
+          <p:cNvPr id="50" name="TextBox 49"/>
           <p:cNvSpPr txBox="1"/>
           <p:nvPr/>
         </p:nvSpPr>
         <p:spPr>
           <a:xfrm>
-            <a:off x="3978000" y="7941600"/>
-            <a:ext cx="2934000" cy="180000"/>
+            <a:off x="2826000" y="4208400"/>
+            <a:ext cx="1908000" cy="216000"/>
           </a:xfrm>
           <a:prstGeom prst="rect">
             <a:avLst/>
@@ -5352,25 +5262,25 @@
             <a:r>
               <a:rPr sz="1050" b="1">
                 <a:solidFill>
-                  <a:srgbClr val="0B5C43"/>
+                  <a:srgbClr val="1B2420"/>
                 </a:solidFill>
                 <a:latin typeface="Tahoma"/>
               </a:rPr>
-              <a:t>K PLUS</a:t>
-            </a:r>
-          </a:p>
-        </p:txBody>
-      </p:sp>
-      <p:sp>
-        <p:nvSpPr>
-          <p:cNvPr id="53" name="TextBox 52"/>
+              <a:t>Daily Auto-Refill</a:t>
+            </a:r>
+          </a:p>
+        </p:txBody>
+      </p:sp>
+      <p:sp>
+        <p:nvSpPr>
+          <p:cNvPr id="51" name="TextBox 50"/>
           <p:cNvSpPr txBox="1"/>
           <p:nvPr/>
         </p:nvSpPr>
         <p:spPr>
           <a:xfrm>
-            <a:off x="3978000" y="8139600"/>
-            <a:ext cx="2934000" cy="630000"/>
+            <a:off x="2826000" y="4406400"/>
+            <a:ext cx="1908000" cy="1044000"/>
           </a:xfrm>
           <a:prstGeom prst="rect">
             <a:avLst/>
@@ -5385,43 +5295,47 @@
           <a:p>
             <a:pPr algn="l">
               <a:lnSpc>
-                <a:spcPct val="122000"/>
+                <a:spcPct val="120000"/>
               </a:lnSpc>
               <a:spcAft>
                 <a:spcPts val="0"/>
               </a:spcAft>
             </a:pPr>
             <a:r>
-              <a:rPr sz="880" b="0">
+              <a:rPr sz="860" b="0">
                 <a:solidFill>
                   <a:srgbClr val="33403A"/>
                 </a:solidFill>
                 <a:latin typeface="Tahoma"/>
               </a:rPr>
-              <a:t>ฟีเจอร์นี้ช่วยเพิ่มความถี่ในการเปิดใช้แอป เปิดโอกาสต่อยอดผลิตภัณฑ์ออมทรัพย์จากพฤติกรรมผู้ใช้จริง และสร้างความแตกต่างที่ชัดเจนจาก Cloud Pocket ของ MAKE by KBank และ Lock Account เดิมของ K PLUS ซึ่งยังไม่มีกลไกปลดล็อกอัตโนมัติในระดับกระเป๋าย่อยแบบนี้</a:t>
-            </a:r>
-          </a:p>
-        </p:txBody>
-      </p:sp>
-      <p:sp>
-        <p:nvSpPr>
-          <p:cNvPr id="54" name="Rectangle 53"/>
+              <a:t>ระบบคำนวณเป้ารายวันจากยอดบัญชีเงินรายเดือนหารด้วยจำนวนวันถึงรอบเงินเข้าถัดไป แล้วเติมกระเป๋ารายวันให้ครบตามเป้าทุกเที่ยงคืน หากใช้เกินเป้า ระบบไม่ปิดกั้น แต่ดึงส่วนที่ขาดจากบัญชีรายเดือนมาเติมทันทีพร้อมแจ้งเตือน</a:t>
+            </a:r>
+          </a:p>
+        </p:txBody>
+      </p:sp>
+      <p:sp>
+        <p:nvSpPr>
+          <p:cNvPr id="52" name="Rounded Rectangle 51"/>
           <p:cNvSpPr/>
           <p:nvPr/>
         </p:nvSpPr>
         <p:spPr>
           <a:xfrm>
-            <a:off x="540000" y="8967599"/>
-            <a:ext cx="6480000" cy="12700"/>
-          </a:xfrm>
-          <a:prstGeom prst="rect">
-            <a:avLst/>
+            <a:off x="4932000" y="4136400"/>
+            <a:ext cx="2088000" cy="1404000"/>
+          </a:xfrm>
+          <a:prstGeom prst="roundRect">
+            <a:avLst>
+              <a:gd name="adj" fmla="val 6000"/>
+            </a:avLst>
           </a:prstGeom>
           <a:solidFill>
-            <a:srgbClr val="DCE8E1"/>
+            <a:srgbClr val="FAFCFB"/>
           </a:solidFill>
-          <a:ln>
-            <a:noFill/>
+          <a:ln w="9525">
+            <a:solidFill>
+              <a:srgbClr val="DCE8E1"/>
+            </a:solidFill>
           </a:ln>
           <a:effectLst/>
         </p:spPr>
@@ -5449,14 +5363,14 @@
       </p:sp>
       <p:sp>
         <p:nvSpPr>
-          <p:cNvPr id="55" name="TextBox 54"/>
+          <p:cNvPr id="53" name="TextBox 52"/>
           <p:cNvSpPr txBox="1"/>
           <p:nvPr/>
         </p:nvSpPr>
         <p:spPr>
           <a:xfrm>
-            <a:off x="540000" y="9021599"/>
-            <a:ext cx="3960000" cy="180000"/>
+            <a:off x="5022000" y="4208400"/>
+            <a:ext cx="1908000" cy="216000"/>
           </a:xfrm>
           <a:prstGeom prst="rect">
             <a:avLst/>
@@ -5478,6 +5392,788 @@
               </a:spcAft>
             </a:pPr>
             <a:r>
+              <a:rPr sz="1050" b="1">
+                <a:solidFill>
+                  <a:srgbClr val="1B2420"/>
+                </a:solidFill>
+                <a:latin typeface="Tahoma"/>
+              </a:rPr>
+              <a:t>กระเป๋านิรภัย (Vault)</a:t>
+            </a:r>
+          </a:p>
+        </p:txBody>
+      </p:sp>
+      <p:sp>
+        <p:nvSpPr>
+          <p:cNvPr id="54" name="TextBox 53"/>
+          <p:cNvSpPr txBox="1"/>
+          <p:nvPr/>
+        </p:nvSpPr>
+        <p:spPr>
+          <a:xfrm>
+            <a:off x="5022000" y="4406400"/>
+            <a:ext cx="1908000" cy="1044000"/>
+          </a:xfrm>
+          <a:prstGeom prst="rect">
+            <a:avLst/>
+          </a:prstGeom>
+          <a:noFill/>
+        </p:spPr>
+        <p:txBody>
+          <a:bodyPr wrap="square" anchor="t" lIns="0" rIns="0" tIns="0" bIns="0">
+            <a:spAutoFit/>
+          </a:bodyPr>
+          <a:lstStyle/>
+          <a:p>
+            <a:pPr algn="l">
+              <a:lnSpc>
+                <a:spcPct val="120000"/>
+              </a:lnSpc>
+              <a:spcAft>
+                <a:spcPts val="0"/>
+              </a:spcAft>
+            </a:pPr>
+            <a:r>
+              <a:rPr sz="860" b="0">
+                <a:solidFill>
+                  <a:srgbClr val="33403A"/>
+                </a:solidFill>
+                <a:latin typeface="Tahoma"/>
+              </a:rPr>
+              <a:t>เงินในกระเป๋านี้ถอนออกไม่ได้ทันที ต้องรอผ่านช่วงเวลาที่กำหนด แล้วระบบปล่อยเงินให้อัตโนมัติ อ้างอิงงานวิจัย commitment device (Ashraf, Karlan &amp; Yin, QJE 2006) ที่พบว่าคนยอมรับกลไกนี้ได้จริงแม้ไม่มีผลตอบแทนพิเศษ</a:t>
+            </a:r>
+          </a:p>
+        </p:txBody>
+      </p:sp>
+      <p:sp>
+        <p:nvSpPr>
+          <p:cNvPr id="55" name="Rounded Rectangle 54"/>
+          <p:cNvSpPr/>
+          <p:nvPr/>
+        </p:nvSpPr>
+        <p:spPr>
+          <a:xfrm>
+            <a:off x="540000" y="5630400"/>
+            <a:ext cx="6480000" cy="468000"/>
+          </a:xfrm>
+          <a:prstGeom prst="roundRect">
+            <a:avLst>
+              <a:gd name="adj" fmla="val 12000"/>
+            </a:avLst>
+          </a:prstGeom>
+          <a:solidFill>
+            <a:srgbClr val="F2F8F5"/>
+          </a:solidFill>
+          <a:ln w="9525">
+            <a:solidFill>
+              <a:srgbClr val="B9D8C7"/>
+            </a:solidFill>
+            <a:prstDash val="dash"/>
+          </a:ln>
+          <a:effectLst/>
+        </p:spPr>
+        <p:style>
+          <a:lnRef idx="1">
+            <a:schemeClr val="accent1"/>
+          </a:lnRef>
+          <a:fillRef idx="3">
+            <a:schemeClr val="accent1"/>
+          </a:fillRef>
+          <a:effectRef idx="2">
+            <a:schemeClr val="accent1"/>
+          </a:effectRef>
+          <a:fontRef idx="minor">
+            <a:schemeClr val="lt1"/>
+          </a:fontRef>
+        </p:style>
+        <p:txBody>
+          <a:bodyPr rtlCol="0" anchor="ctr"/>
+          <a:lstStyle/>
+          <a:p>
+            <a:pPr algn="ctr"/>
+          </a:p>
+        </p:txBody>
+      </p:sp>
+      <p:sp>
+        <p:nvSpPr>
+          <p:cNvPr id="56" name="TextBox 55"/>
+          <p:cNvSpPr txBox="1"/>
+          <p:nvPr/>
+        </p:nvSpPr>
+        <p:spPr>
+          <a:xfrm>
+            <a:off x="648000" y="5684400"/>
+            <a:ext cx="6264000" cy="360000"/>
+          </a:xfrm>
+          <a:prstGeom prst="rect">
+            <a:avLst/>
+          </a:prstGeom>
+          <a:noFill/>
+        </p:spPr>
+        <p:txBody>
+          <a:bodyPr wrap="square" anchor="t" lIns="0" rIns="0" tIns="0" bIns="0">
+            <a:spAutoFit/>
+          </a:bodyPr>
+          <a:lstStyle/>
+          <a:p>
+            <a:pPr algn="l">
+              <a:lnSpc>
+                <a:spcPct val="120000"/>
+              </a:lnSpc>
+              <a:spcAft>
+                <a:spcPts val="0"/>
+              </a:spcAft>
+            </a:pPr>
+            <a:r>
+              <a:rPr sz="860" b="1">
+                <a:solidFill>
+                  <a:srgbClr val="0B5C43"/>
+                </a:solidFill>
+                <a:latin typeface="Tahoma"/>
+              </a:rPr>
+              <a:t>จุดเล็กๆ ที่ใส่ใจ: </a:t>
+            </a:r>
+            <a:r>
+              <a:rPr sz="860" b="0">
+                <a:solidFill>
+                  <a:srgbClr val="33403A"/>
+                </a:solidFill>
+                <a:latin typeface="Tahoma"/>
+              </a:rPr>
+              <a:t>หน้าจอกระเป๋านิรภัยมีต้นไม้ที่โตขึ้นเป็นระยะตามจำนวนรอบที่ออมต่อเนื่อง ไม่ใช่ยอดเงิน คนเงินเดือนน้อยจึงโตได้เท่าคนเงินเดือนมาก และถอนเงินก็ไม่ทำให้ต้นไม้ตาย เป็นแรงจูงใจง่ายๆ ให้อยากกลับมาออมสม่ำเสมอ</a:t>
+            </a:r>
+          </a:p>
+        </p:txBody>
+      </p:sp>
+      <p:sp>
+        <p:nvSpPr>
+          <p:cNvPr id="57" name="TextBox 56"/>
+          <p:cNvSpPr txBox="1"/>
+          <p:nvPr/>
+        </p:nvSpPr>
+        <p:spPr>
+          <a:xfrm>
+            <a:off x="540000" y="6242400"/>
+            <a:ext cx="3150000" cy="251999"/>
+          </a:xfrm>
+          <a:prstGeom prst="rect">
+            <a:avLst/>
+          </a:prstGeom>
+          <a:noFill/>
+        </p:spPr>
+        <p:txBody>
+          <a:bodyPr wrap="square" anchor="t" lIns="0" rIns="0" tIns="0" bIns="0">
+            <a:spAutoFit/>
+          </a:bodyPr>
+          <a:lstStyle/>
+          <a:p>
+            <a:pPr algn="l">
+              <a:lnSpc>
+                <a:spcPct val="115000"/>
+              </a:lnSpc>
+              <a:spcAft>
+                <a:spcPts val="0"/>
+              </a:spcAft>
+            </a:pPr>
+            <a:r>
+              <a:rPr sz="1500" b="1">
+                <a:solidFill>
+                  <a:srgbClr val="0B5C43"/>
+                </a:solidFill>
+                <a:latin typeface="Tahoma"/>
+              </a:rPr>
+              <a:t>Target Users</a:t>
+            </a:r>
+          </a:p>
+        </p:txBody>
+      </p:sp>
+      <p:sp>
+        <p:nvSpPr>
+          <p:cNvPr id="58" name="TextBox 57"/>
+          <p:cNvSpPr txBox="1"/>
+          <p:nvPr/>
+        </p:nvSpPr>
+        <p:spPr>
+          <a:xfrm>
+            <a:off x="540000" y="6465600"/>
+            <a:ext cx="3150000" cy="1440000"/>
+          </a:xfrm>
+          <a:prstGeom prst="rect">
+            <a:avLst/>
+          </a:prstGeom>
+          <a:noFill/>
+        </p:spPr>
+        <p:txBody>
+          <a:bodyPr wrap="square" anchor="t" lIns="0" rIns="0" tIns="0" bIns="0">
+            <a:spAutoFit/>
+          </a:bodyPr>
+          <a:lstStyle/>
+          <a:p>
+            <a:pPr algn="l">
+              <a:lnSpc>
+                <a:spcPct val="128000"/>
+              </a:lnSpc>
+              <a:spcAft>
+                <a:spcPts val="0"/>
+              </a:spcAft>
+            </a:pPr>
+            <a:r>
+              <a:rPr sz="930" b="0">
+                <a:solidFill>
+                  <a:srgbClr val="1B2420"/>
+                </a:solidFill>
+                <a:latin typeface="Tahoma"/>
+              </a:rPr>
+              <a:t>ผู้ใช้ K PLUS อายุ 22–30 ปี กลุ่ม First Jobbers ที่รายได้ปานกลางถึงจำกัด เช่น พนักงานออฟฟิศเงินเดือน 22,500 บาทที่เข้าตรงเวลาทุกเดือน หรือฟรีแลนซ์ที่ลูกค้าโอนเงินไม่ตรงงวด คนกลุ่มนี้มีรายรับแต่จัดสรรเงินเองไม่ทัน โดยเฉพาะกลุ่มที่เช่าบ้านหรือคอนโดในเมืองซึ่งค่าครองชีพสูงเมื่อเทียบกับรายได้</a:t>
+            </a:r>
+          </a:p>
+        </p:txBody>
+      </p:sp>
+      <p:sp>
+        <p:nvSpPr>
+          <p:cNvPr id="59" name="TextBox 58"/>
+          <p:cNvSpPr txBox="1"/>
+          <p:nvPr/>
+        </p:nvSpPr>
+        <p:spPr>
+          <a:xfrm>
+            <a:off x="3870000" y="6242400"/>
+            <a:ext cx="3150000" cy="251999"/>
+          </a:xfrm>
+          <a:prstGeom prst="rect">
+            <a:avLst/>
+          </a:prstGeom>
+          <a:noFill/>
+        </p:spPr>
+        <p:txBody>
+          <a:bodyPr wrap="square" anchor="t" lIns="0" rIns="0" tIns="0" bIns="0">
+            <a:spAutoFit/>
+          </a:bodyPr>
+          <a:lstStyle/>
+          <a:p>
+            <a:pPr algn="l">
+              <a:lnSpc>
+                <a:spcPct val="115000"/>
+              </a:lnSpc>
+              <a:spcAft>
+                <a:spcPts val="0"/>
+              </a:spcAft>
+            </a:pPr>
+            <a:r>
+              <a:rPr sz="1500" b="1">
+                <a:solidFill>
+                  <a:srgbClr val="0B5C43"/>
+                </a:solidFill>
+                <a:latin typeface="Tahoma"/>
+              </a:rPr>
+              <a:t>Track Perspective — Track 1</a:t>
+            </a:r>
+          </a:p>
+        </p:txBody>
+      </p:sp>
+      <p:sp>
+        <p:nvSpPr>
+          <p:cNvPr id="60" name="TextBox 59"/>
+          <p:cNvSpPr txBox="1"/>
+          <p:nvPr/>
+        </p:nvSpPr>
+        <p:spPr>
+          <a:xfrm>
+            <a:off x="3870000" y="6465600"/>
+            <a:ext cx="3150000" cy="540000"/>
+          </a:xfrm>
+          <a:prstGeom prst="rect">
+            <a:avLst/>
+          </a:prstGeom>
+          <a:noFill/>
+        </p:spPr>
+        <p:txBody>
+          <a:bodyPr wrap="square" anchor="t" lIns="0" rIns="0" tIns="0" bIns="0">
+            <a:spAutoFit/>
+          </a:bodyPr>
+          <a:lstStyle/>
+          <a:p>
+            <a:pPr algn="l">
+              <a:lnSpc>
+                <a:spcPct val="122000"/>
+              </a:lnSpc>
+              <a:spcAft>
+                <a:spcPts val="0"/>
+              </a:spcAft>
+            </a:pPr>
+            <a:r>
+              <a:rPr sz="930" b="0">
+                <a:solidFill>
+                  <a:srgbClr val="1B2420"/>
+                </a:solidFill>
+                <a:latin typeface="Tahoma"/>
+              </a:rPr>
+              <a:t>ด้านการพัฒนา แยก rule engine เป็นโมดูลที่ทดสอบง่าย ให้สถานะรอถอนเงินอ้างอิงจากเซิร์ฟเวอร์เท่านั้น และบันทึกทุกรายการผ่าน ledger ที่เขียนทางเดียว</a:t>
+            </a:r>
+          </a:p>
+        </p:txBody>
+      </p:sp>
+      <p:sp>
+        <p:nvSpPr>
+          <p:cNvPr id="61" name="TextBox 60"/>
+          <p:cNvSpPr txBox="1"/>
+          <p:nvPr/>
+        </p:nvSpPr>
+        <p:spPr>
+          <a:xfrm>
+            <a:off x="3870000" y="6976800"/>
+            <a:ext cx="3150000" cy="540000"/>
+          </a:xfrm>
+          <a:prstGeom prst="rect">
+            <a:avLst/>
+          </a:prstGeom>
+          <a:noFill/>
+        </p:spPr>
+        <p:txBody>
+          <a:bodyPr wrap="square" anchor="t" lIns="0" rIns="0" tIns="0" bIns="0">
+            <a:spAutoFit/>
+          </a:bodyPr>
+          <a:lstStyle/>
+          <a:p>
+            <a:pPr algn="l">
+              <a:lnSpc>
+                <a:spcPct val="122000"/>
+              </a:lnSpc>
+              <a:spcAft>
+                <a:spcPts val="0"/>
+              </a:spcAft>
+            </a:pPr>
+            <a:r>
+              <a:rPr sz="930" b="0">
+                <a:solidFill>
+                  <a:srgbClr val="1B2420"/>
+                </a:solidFill>
+                <a:latin typeface="Tahoma"/>
+              </a:rPr>
+              <a:t>ด้านการทดสอบ ใช้ property test สุ่มธุรกรรมกว่าหมื่นรายการยืนยันว่ายอดเงินทุกบัญชีถูกต้องเสมอ ร่วมกับ unit และ integration test ครอบคลุมกรณีย่อยกว่า 50 จุด รวมถึง idempotency และ concurrency</a:t>
+            </a:r>
+          </a:p>
+        </p:txBody>
+      </p:sp>
+      <p:sp>
+        <p:nvSpPr>
+          <p:cNvPr id="62" name="TextBox 61"/>
+          <p:cNvSpPr txBox="1"/>
+          <p:nvPr/>
+        </p:nvSpPr>
+        <p:spPr>
+          <a:xfrm>
+            <a:off x="3870000" y="7488000"/>
+            <a:ext cx="3150000" cy="540000"/>
+          </a:xfrm>
+          <a:prstGeom prst="rect">
+            <a:avLst/>
+          </a:prstGeom>
+          <a:noFill/>
+        </p:spPr>
+        <p:txBody>
+          <a:bodyPr wrap="square" anchor="t" lIns="0" rIns="0" tIns="0" bIns="0">
+            <a:spAutoFit/>
+          </a:bodyPr>
+          <a:lstStyle/>
+          <a:p>
+            <a:pPr algn="l">
+              <a:lnSpc>
+                <a:spcPct val="122000"/>
+              </a:lnSpc>
+              <a:spcAft>
+                <a:spcPts val="0"/>
+              </a:spcAft>
+            </a:pPr>
+            <a:r>
+              <a:rPr sz="930" b="0">
+                <a:solidFill>
+                  <a:srgbClr val="1B2420"/>
+                </a:solidFill>
+                <a:latin typeface="Tahoma"/>
+              </a:rPr>
+              <a:t>ด้านคุณภาพ วางแผนทดสอบกับผู้ใช้จริง 5–8 คนตาม protocol ที่กำหนดล่วงหน้า พร้อม checklist ตามหลัก PDPA</a:t>
+            </a:r>
+          </a:p>
+        </p:txBody>
+      </p:sp>
+      <p:sp>
+        <p:nvSpPr>
+          <p:cNvPr id="63" name="TextBox 62"/>
+          <p:cNvSpPr txBox="1"/>
+          <p:nvPr/>
+        </p:nvSpPr>
+        <p:spPr>
+          <a:xfrm>
+            <a:off x="540000" y="8366400"/>
+            <a:ext cx="6480000" cy="251999"/>
+          </a:xfrm>
+          <a:prstGeom prst="rect">
+            <a:avLst/>
+          </a:prstGeom>
+          <a:noFill/>
+        </p:spPr>
+        <p:txBody>
+          <a:bodyPr wrap="square" anchor="t" lIns="0" rIns="0" tIns="0" bIns="0">
+            <a:spAutoFit/>
+          </a:bodyPr>
+          <a:lstStyle/>
+          <a:p>
+            <a:pPr algn="l">
+              <a:lnSpc>
+                <a:spcPct val="115000"/>
+              </a:lnSpc>
+              <a:spcAft>
+                <a:spcPts val="0"/>
+              </a:spcAft>
+            </a:pPr>
+            <a:r>
+              <a:rPr sz="1500" b="1">
+                <a:solidFill>
+                  <a:srgbClr val="0B5C43"/>
+                </a:solidFill>
+                <a:latin typeface="Tahoma"/>
+              </a:rPr>
+              <a:t>Value Proposition</a:t>
+            </a:r>
+          </a:p>
+        </p:txBody>
+      </p:sp>
+      <p:sp>
+        <p:nvSpPr>
+          <p:cNvPr id="64" name="Rounded Rectangle 63"/>
+          <p:cNvSpPr/>
+          <p:nvPr/>
+        </p:nvSpPr>
+        <p:spPr>
+          <a:xfrm>
+            <a:off x="540000" y="8589600"/>
+            <a:ext cx="3150000" cy="972000"/>
+          </a:xfrm>
+          <a:prstGeom prst="roundRect">
+            <a:avLst>
+              <a:gd name="adj" fmla="val 8000"/>
+            </a:avLst>
+          </a:prstGeom>
+          <a:solidFill>
+            <a:srgbClr val="F2F8F5"/>
+          </a:solidFill>
+          <a:ln>
+            <a:noFill/>
+          </a:ln>
+          <a:effectLst/>
+        </p:spPr>
+        <p:style>
+          <a:lnRef idx="1">
+            <a:schemeClr val="accent1"/>
+          </a:lnRef>
+          <a:fillRef idx="3">
+            <a:schemeClr val="accent1"/>
+          </a:fillRef>
+          <a:effectRef idx="2">
+            <a:schemeClr val="accent1"/>
+          </a:effectRef>
+          <a:fontRef idx="minor">
+            <a:schemeClr val="lt1"/>
+          </a:fontRef>
+        </p:style>
+        <p:txBody>
+          <a:bodyPr rtlCol="0" anchor="ctr"/>
+          <a:lstStyle/>
+          <a:p>
+            <a:pPr algn="ctr"/>
+          </a:p>
+        </p:txBody>
+      </p:sp>
+      <p:sp>
+        <p:nvSpPr>
+          <p:cNvPr id="65" name="TextBox 64"/>
+          <p:cNvSpPr txBox="1"/>
+          <p:nvPr/>
+        </p:nvSpPr>
+        <p:spPr>
+          <a:xfrm>
+            <a:off x="648000" y="8661600"/>
+            <a:ext cx="2934000" cy="180000"/>
+          </a:xfrm>
+          <a:prstGeom prst="rect">
+            <a:avLst/>
+          </a:prstGeom>
+          <a:noFill/>
+        </p:spPr>
+        <p:txBody>
+          <a:bodyPr wrap="square" anchor="t" lIns="0" rIns="0" tIns="0" bIns="0">
+            <a:spAutoFit/>
+          </a:bodyPr>
+          <a:lstStyle/>
+          <a:p>
+            <a:pPr algn="l">
+              <a:lnSpc>
+                <a:spcPct val="115000"/>
+              </a:lnSpc>
+              <a:spcAft>
+                <a:spcPts val="0"/>
+              </a:spcAft>
+            </a:pPr>
+            <a:r>
+              <a:rPr sz="1050" b="1">
+                <a:solidFill>
+                  <a:srgbClr val="0B5C43"/>
+                </a:solidFill>
+                <a:latin typeface="Tahoma"/>
+              </a:rPr>
+              <a:t>ผู้ใช้</a:t>
+            </a:r>
+          </a:p>
+        </p:txBody>
+      </p:sp>
+      <p:sp>
+        <p:nvSpPr>
+          <p:cNvPr id="66" name="TextBox 65"/>
+          <p:cNvSpPr txBox="1"/>
+          <p:nvPr/>
+        </p:nvSpPr>
+        <p:spPr>
+          <a:xfrm>
+            <a:off x="648000" y="8859600"/>
+            <a:ext cx="2934000" cy="630000"/>
+          </a:xfrm>
+          <a:prstGeom prst="rect">
+            <a:avLst/>
+          </a:prstGeom>
+          <a:noFill/>
+        </p:spPr>
+        <p:txBody>
+          <a:bodyPr wrap="square" anchor="t" lIns="0" rIns="0" tIns="0" bIns="0">
+            <a:spAutoFit/>
+          </a:bodyPr>
+          <a:lstStyle/>
+          <a:p>
+            <a:pPr algn="l">
+              <a:lnSpc>
+                <a:spcPct val="122000"/>
+              </a:lnSpc>
+              <a:spcAft>
+                <a:spcPts val="0"/>
+              </a:spcAft>
+            </a:pPr>
+            <a:r>
+              <a:rPr sz="880" b="0">
+                <a:solidFill>
+                  <a:srgbClr val="33403A"/>
+                </a:solidFill>
+                <a:latin typeface="Tahoma"/>
+              </a:rPr>
+              <a:t>ผู้ใช้ไม่ต้องแบ่งเงินเอง เห็นเงินออมของตัวเองเติบโตขึ้นอย่างเป็นระบบ และมีเวลาคิดทบทวนมากขึ้นก่อนจะใช้เงินก้อนที่ออมไว้ ซึ่งในกรณีที่กำลังจะโอนเงินออมให้มิจฉาชีพโดยไม่ทันคิด ช่วงเวลารอนี้อาจช่วยลดความเสียหายได้บ้าง</a:t>
+            </a:r>
+          </a:p>
+        </p:txBody>
+      </p:sp>
+      <p:sp>
+        <p:nvSpPr>
+          <p:cNvPr id="67" name="Rounded Rectangle 66"/>
+          <p:cNvSpPr/>
+          <p:nvPr/>
+        </p:nvSpPr>
+        <p:spPr>
+          <a:xfrm>
+            <a:off x="3870000" y="8589600"/>
+            <a:ext cx="3150000" cy="972000"/>
+          </a:xfrm>
+          <a:prstGeom prst="roundRect">
+            <a:avLst>
+              <a:gd name="adj" fmla="val 8000"/>
+            </a:avLst>
+          </a:prstGeom>
+          <a:solidFill>
+            <a:srgbClr val="F2F8F5"/>
+          </a:solidFill>
+          <a:ln>
+            <a:noFill/>
+          </a:ln>
+          <a:effectLst/>
+        </p:spPr>
+        <p:style>
+          <a:lnRef idx="1">
+            <a:schemeClr val="accent1"/>
+          </a:lnRef>
+          <a:fillRef idx="3">
+            <a:schemeClr val="accent1"/>
+          </a:fillRef>
+          <a:effectRef idx="2">
+            <a:schemeClr val="accent1"/>
+          </a:effectRef>
+          <a:fontRef idx="minor">
+            <a:schemeClr val="lt1"/>
+          </a:fontRef>
+        </p:style>
+        <p:txBody>
+          <a:bodyPr rtlCol="0" anchor="ctr"/>
+          <a:lstStyle/>
+          <a:p>
+            <a:pPr algn="ctr"/>
+          </a:p>
+        </p:txBody>
+      </p:sp>
+      <p:sp>
+        <p:nvSpPr>
+          <p:cNvPr id="68" name="TextBox 67"/>
+          <p:cNvSpPr txBox="1"/>
+          <p:nvPr/>
+        </p:nvSpPr>
+        <p:spPr>
+          <a:xfrm>
+            <a:off x="3978000" y="8661600"/>
+            <a:ext cx="2934000" cy="180000"/>
+          </a:xfrm>
+          <a:prstGeom prst="rect">
+            <a:avLst/>
+          </a:prstGeom>
+          <a:noFill/>
+        </p:spPr>
+        <p:txBody>
+          <a:bodyPr wrap="square" anchor="t" lIns="0" rIns="0" tIns="0" bIns="0">
+            <a:spAutoFit/>
+          </a:bodyPr>
+          <a:lstStyle/>
+          <a:p>
+            <a:pPr algn="l">
+              <a:lnSpc>
+                <a:spcPct val="115000"/>
+              </a:lnSpc>
+              <a:spcAft>
+                <a:spcPts val="0"/>
+              </a:spcAft>
+            </a:pPr>
+            <a:r>
+              <a:rPr sz="1050" b="1">
+                <a:solidFill>
+                  <a:srgbClr val="0B5C43"/>
+                </a:solidFill>
+                <a:latin typeface="Tahoma"/>
+              </a:rPr>
+              <a:t>K PLUS</a:t>
+            </a:r>
+          </a:p>
+        </p:txBody>
+      </p:sp>
+      <p:sp>
+        <p:nvSpPr>
+          <p:cNvPr id="69" name="TextBox 68"/>
+          <p:cNvSpPr txBox="1"/>
+          <p:nvPr/>
+        </p:nvSpPr>
+        <p:spPr>
+          <a:xfrm>
+            <a:off x="3978000" y="8859600"/>
+            <a:ext cx="2934000" cy="630000"/>
+          </a:xfrm>
+          <a:prstGeom prst="rect">
+            <a:avLst/>
+          </a:prstGeom>
+          <a:noFill/>
+        </p:spPr>
+        <p:txBody>
+          <a:bodyPr wrap="square" anchor="t" lIns="0" rIns="0" tIns="0" bIns="0">
+            <a:spAutoFit/>
+          </a:bodyPr>
+          <a:lstStyle/>
+          <a:p>
+            <a:pPr algn="l">
+              <a:lnSpc>
+                <a:spcPct val="122000"/>
+              </a:lnSpc>
+              <a:spcAft>
+                <a:spcPts val="0"/>
+              </a:spcAft>
+            </a:pPr>
+            <a:r>
+              <a:rPr sz="880" b="0">
+                <a:solidFill>
+                  <a:srgbClr val="33403A"/>
+                </a:solidFill>
+                <a:latin typeface="Tahoma"/>
+              </a:rPr>
+              <a:t>ฟีเจอร์นี้ช่วยเพิ่มความถี่ในการเปิดใช้แอป เปิดโอกาสต่อยอดผลิตภัณฑ์ออมทรัพย์จากพฤติกรรมผู้ใช้จริง และสร้างความแตกต่างที่ชัดเจนจาก Cloud Pocket ของ MAKE by KBank และ Lock Account เดิมของ K PLUS ซึ่งยังไม่มีกลไกปลดล็อกอัตโนมัติในระดับกระเป๋าย่อยแบบนี้</a:t>
+            </a:r>
+          </a:p>
+        </p:txBody>
+      </p:sp>
+      <p:sp>
+        <p:nvSpPr>
+          <p:cNvPr id="70" name="Rectangle 69"/>
+          <p:cNvSpPr/>
+          <p:nvPr/>
+        </p:nvSpPr>
+        <p:spPr>
+          <a:xfrm>
+            <a:off x="540000" y="9687599"/>
+            <a:ext cx="6480000" cy="12700"/>
+          </a:xfrm>
+          <a:prstGeom prst="rect">
+            <a:avLst/>
+          </a:prstGeom>
+          <a:solidFill>
+            <a:srgbClr val="DCE8E1"/>
+          </a:solidFill>
+          <a:ln>
+            <a:noFill/>
+          </a:ln>
+          <a:effectLst/>
+        </p:spPr>
+        <p:style>
+          <a:lnRef idx="1">
+            <a:schemeClr val="accent1"/>
+          </a:lnRef>
+          <a:fillRef idx="3">
+            <a:schemeClr val="accent1"/>
+          </a:fillRef>
+          <a:effectRef idx="2">
+            <a:schemeClr val="accent1"/>
+          </a:effectRef>
+          <a:fontRef idx="minor">
+            <a:schemeClr val="lt1"/>
+          </a:fontRef>
+        </p:style>
+        <p:txBody>
+          <a:bodyPr rtlCol="0" anchor="ctr"/>
+          <a:lstStyle/>
+          <a:p>
+            <a:pPr algn="ctr"/>
+          </a:p>
+        </p:txBody>
+      </p:sp>
+      <p:sp>
+        <p:nvSpPr>
+          <p:cNvPr id="71" name="TextBox 70"/>
+          <p:cNvSpPr txBox="1"/>
+          <p:nvPr/>
+        </p:nvSpPr>
+        <p:spPr>
+          <a:xfrm>
+            <a:off x="540000" y="9741599"/>
+            <a:ext cx="3960000" cy="180000"/>
+          </a:xfrm>
+          <a:prstGeom prst="rect">
+            <a:avLst/>
+          </a:prstGeom>
+          <a:noFill/>
+        </p:spPr>
+        <p:txBody>
+          <a:bodyPr wrap="square" anchor="t" lIns="0" rIns="0" tIns="0" bIns="0">
+            <a:spAutoFit/>
+          </a:bodyPr>
+          <a:lstStyle/>
+          <a:p>
+            <a:pPr algn="l">
+              <a:lnSpc>
+                <a:spcPct val="115000"/>
+              </a:lnSpc>
+              <a:spcAft>
+                <a:spcPts val="0"/>
+              </a:spcAft>
+            </a:pPr>
+            <a:r>
               <a:rPr sz="760" b="0">
                 <a:solidFill>
                   <a:srgbClr val="5A6A5F"/>
@@ -5491,13 +6187,13 @@
       </p:sp>
       <p:sp>
         <p:nvSpPr>
-          <p:cNvPr id="56" name="TextBox 55"/>
+          <p:cNvPr id="72" name="TextBox 71"/>
           <p:cNvSpPr txBox="1"/>
           <p:nvPr/>
         </p:nvSpPr>
         <p:spPr>
           <a:xfrm>
-            <a:off x="4860000" y="9021599"/>
+            <a:off x="4860000" y="9741599"/>
             <a:ext cx="2160000" cy="180000"/>
           </a:xfrm>
           <a:prstGeom prst="rect">
@@ -5533,13 +6229,13 @@
       </p:sp>
       <p:sp>
         <p:nvSpPr>
-          <p:cNvPr id="57" name="Rectangle 56"/>
+          <p:cNvPr id="73" name="Rectangle 72"/>
           <p:cNvSpPr/>
           <p:nvPr/>
         </p:nvSpPr>
         <p:spPr>
           <a:xfrm>
-            <a:off x="0" y="9219599"/>
+            <a:off x="0" y="9939599"/>
             <a:ext cx="7560000" cy="792000"/>
           </a:xfrm>
           <a:prstGeom prst="rect">
@@ -5585,13 +6281,13 @@
       </p:sp>
       <p:sp>
         <p:nvSpPr>
-          <p:cNvPr id="58" name="TextBox 57"/>
+          <p:cNvPr id="74" name="TextBox 73"/>
           <p:cNvSpPr txBox="1"/>
           <p:nvPr/>
         </p:nvSpPr>
         <p:spPr>
           <a:xfrm>
-            <a:off x="360000" y="9298799"/>
+            <a:off x="360000" y="10018799"/>
             <a:ext cx="6840000" cy="216000"/>
           </a:xfrm>
           <a:prstGeom prst="rect">
@@ -5627,13 +6323,13 @@
       </p:sp>
       <p:sp>
         <p:nvSpPr>
-          <p:cNvPr id="59" name="Rounded Rectangle 58"/>
+          <p:cNvPr id="75" name="Rounded Rectangle 74"/>
           <p:cNvSpPr/>
           <p:nvPr/>
         </p:nvSpPr>
         <p:spPr>
           <a:xfrm>
-            <a:off x="810000" y="9525599"/>
+            <a:off x="810000" y="10245599"/>
             <a:ext cx="5940000" cy="306000"/>
           </a:xfrm>
           <a:prstGeom prst="roundRect">
@@ -5675,13 +6371,13 @@
       </p:sp>
       <p:sp>
         <p:nvSpPr>
-          <p:cNvPr id="60" name="TextBox 59"/>
+          <p:cNvPr id="76" name="TextBox 75"/>
           <p:cNvSpPr txBox="1"/>
           <p:nvPr/>
         </p:nvSpPr>
         <p:spPr>
           <a:xfrm>
-            <a:off x="810000" y="9525599"/>
+            <a:off x="810000" y="10245599"/>
             <a:ext cx="5940000" cy="306000"/>
           </a:xfrm>
           <a:prstGeom prst="rect">

</xml_diff>